<commit_message>
docs: Cross-ref Case 2 (Price), update PDFs and deck to reflect 9/10 score
- Add cross-referenced doc set for Case 2024-DR-15-0341 (5 docs)
- Update demo-guide PDF with 4-step document improvement journey (Act 4b)
- Update summary and slide-outline PDFs with 9/10 scoring
- Regenerate all sharepoint-docs DOCX/PDF with cross-ref headers
- Add doc-retest results (GCC cross-ref only testing)
- Update session log through Session 32

Co-Authored-By: Claude Opus 4.6 <noreply@anthropic.com>
</commit_message>
<xml_diff>
--- a/decks/agent-accuracy-spectrum.pptx
+++ b/decks/agent-accuracy-spectrum.pptx
@@ -20893,7 +20893,7 @@
               </a:spcAft>
             </a:pPr>
             <a:r>
-              <a:rPr sz="1500">
+              <a:rPr sz="1400">
                 <a:solidFill>
                   <a:srgbClr val="2D2D2D"/>
                 </a:solidFill>
@@ -20909,7 +20909,7 @@
               </a:spcAft>
             </a:pPr>
             <a:r>
-              <a:rPr sz="1500">
+              <a:rPr sz="1400">
                 <a:solidFill>
                   <a:srgbClr val="2D2D2D"/>
                 </a:solidFill>
@@ -20925,7 +20925,23 @@
               </a:spcAft>
             </a:pPr>
             <a:r>
-              <a:rPr sz="1500">
+              <a:rPr sz="1400">
+                <a:solidFill>
+                  <a:srgbClr val="2D2D2D"/>
+                </a:solidFill>
+                <a:latin typeface="Calibri"/>
+              </a:rPr>
+              <a:t>GCC agent: 3/10 to 9/10 -- same model, same platform, just better documents</a:t>
+            </a:r>
+          </a:p>
+          <a:p>
+            <a:pPr>
+              <a:spcAft>
+                <a:spcPts val="600"/>
+              </a:spcAft>
+            </a:pPr>
+            <a:r>
+              <a:rPr sz="1400">
                 <a:solidFill>
                   <a:srgbClr val="2D2D2D"/>
                 </a:solidFill>

</xml_diff>

<commit_message>
docs: Retest all UC1 document agents, finalize whitepaper v1.0
Retested all 6 previously-untested UC1 document agents with cross-referenced
documents (380 total test runs). Updated scores across whitepaper, slide
outline, demo guide, FAQs, and PowerPoint deck. Fixed "Start at Level 1"
collision with five-level framework terminology.

Co-Authored-By: Claude Opus 4.6 <noreply@anthropic.com>
</commit_message>
<xml_diff>
--- a/decks/agent-accuracy-spectrum.pptx
+++ b/decks/agent-accuracy-spectrum.pptx
@@ -4168,7 +4168,7 @@
               </a:defRPr>
             </a:pPr>
             <a:r>
-              <a:t>Findings from 313 Test Runs Across 19 Agent Configurations</a:t>
+              <a:t>Findings from 380 Test Runs Across 19 Agent Configurations</a:t>
             </a:r>
           </a:p>
         </p:txBody>
@@ -4505,7 +4505,7 @@
               </a:defRPr>
             </a:pPr>
             <a:r>
-              <a:t>313 test runs  |  19 agents  |  21 slides  |  2 use cases</a:t>
+              <a:t>380 test runs  |  19 agents  |  21 slides  |  2 use cases</a:t>
             </a:r>
           </a:p>
         </p:txBody>
@@ -5307,7 +5307,7 @@
               </a:defRPr>
             </a:pPr>
             <a:r>
-              <a:t>These are not hypothetical. We documented each one across 313 test runs.</a:t>
+              <a:t>These are not hypothetical. We documented each one across 380 test runs.</a:t>
             </a:r>
           </a:p>
         </p:txBody>

</xml_diff>